<commit_message>
Add comments, modify presentation
</commit_message>
<xml_diff>
--- a/Presentations/StateBasedProgramming-Friday7PM.pptx
+++ b/Presentations/StateBasedProgramming-Friday7PM.pptx
@@ -1,6 +1,6 @@
 
 <file path=ppt/presentation.xml><?xml version="1.0" encoding="utf-8"?>
-<p:presentation xmlns:a="http://schemas.openxmlformats.org/drawingml/2006/main" xmlns:r="http://schemas.openxmlformats.org/officeDocument/2006/relationships" xmlns:p="http://schemas.openxmlformats.org/presentationml/2006/main" saveSubsetFonts="1">
+<p:presentation xmlns:a="http://schemas.openxmlformats.org/drawingml/2006/main" xmlns:r="http://schemas.openxmlformats.org/officeDocument/2006/relationships" xmlns:p="http://schemas.openxmlformats.org/presentationml/2006/main" embedTrueTypeFonts="1" saveSubsetFonts="1">
   <p:sldMasterIdLst>
     <p:sldMasterId id="2147483648" r:id="rId1"/>
   </p:sldMasterIdLst>
@@ -15,9 +15,21 @@
     <p:sldId id="261" r:id="rId9"/>
     <p:sldId id="262" r:id="rId10"/>
     <p:sldId id="263" r:id="rId11"/>
+    <p:sldId id="266" r:id="rId12"/>
   </p:sldIdLst>
   <p:sldSz cx="12192000" cy="6858000"/>
   <p:notesSz cx="6858000" cy="9144000"/>
+  <p:embeddedFontLst>
+    <p:embeddedFont>
+      <p:font typeface="Bahnschrift" panose="020B0502040204020203" pitchFamily="34" charset="0"/>
+      <p:regular r:id="rId13"/>
+      <p:bold r:id="rId14"/>
+    </p:embeddedFont>
+    <p:embeddedFont>
+      <p:font typeface="Black Ops One" pitchFamily="2" charset="0"/>
+      <p:regular r:id="rId15"/>
+    </p:embeddedFont>
+  </p:embeddedFontLst>
   <p:defaultTextStyle>
     <a:defPPr>
       <a:defRPr lang="en-US"/>
@@ -3551,7 +3563,7 @@
           <a:p>
             <a:fld id="{B765778D-E9C8-418F-BCC2-C3C72FDE59B3}" type="datetimeFigureOut">
               <a:rPr lang="en-US" smtClean="0"/>
-              <a:t>8/7/2026</a:t>
+              <a:t>8/10/2026</a:t>
             </a:fld>
             <a:endParaRPr lang="en-US" dirty="0"/>
           </a:p>
@@ -3749,7 +3761,7 @@
           <a:p>
             <a:fld id="{B765778D-E9C8-418F-BCC2-C3C72FDE59B3}" type="datetimeFigureOut">
               <a:rPr lang="en-US" smtClean="0"/>
-              <a:t>8/7/2026</a:t>
+              <a:t>8/10/2026</a:t>
             </a:fld>
             <a:endParaRPr lang="en-US" dirty="0"/>
           </a:p>
@@ -3957,7 +3969,7 @@
           <a:p>
             <a:fld id="{B765778D-E9C8-418F-BCC2-C3C72FDE59B3}" type="datetimeFigureOut">
               <a:rPr lang="en-US" smtClean="0"/>
-              <a:t>8/7/2026</a:t>
+              <a:t>8/10/2026</a:t>
             </a:fld>
             <a:endParaRPr lang="en-US" dirty="0"/>
           </a:p>
@@ -4155,7 +4167,7 @@
           <a:p>
             <a:fld id="{B765778D-E9C8-418F-BCC2-C3C72FDE59B3}" type="datetimeFigureOut">
               <a:rPr lang="en-US" smtClean="0"/>
-              <a:t>8/7/2026</a:t>
+              <a:t>8/10/2026</a:t>
             </a:fld>
             <a:endParaRPr lang="en-US" dirty="0"/>
           </a:p>
@@ -4430,7 +4442,7 @@
           <a:p>
             <a:fld id="{B765778D-E9C8-418F-BCC2-C3C72FDE59B3}" type="datetimeFigureOut">
               <a:rPr lang="en-US" smtClean="0"/>
-              <a:t>8/7/2026</a:t>
+              <a:t>8/10/2026</a:t>
             </a:fld>
             <a:endParaRPr lang="en-US" dirty="0"/>
           </a:p>
@@ -4695,7 +4707,7 @@
           <a:p>
             <a:fld id="{B765778D-E9C8-418F-BCC2-C3C72FDE59B3}" type="datetimeFigureOut">
               <a:rPr lang="en-US" smtClean="0"/>
-              <a:t>8/7/2026</a:t>
+              <a:t>8/10/2026</a:t>
             </a:fld>
             <a:endParaRPr lang="en-US" dirty="0"/>
           </a:p>
@@ -5107,7 +5119,7 @@
           <a:p>
             <a:fld id="{B765778D-E9C8-418F-BCC2-C3C72FDE59B3}" type="datetimeFigureOut">
               <a:rPr lang="en-US" smtClean="0"/>
-              <a:t>8/7/2026</a:t>
+              <a:t>8/10/2026</a:t>
             </a:fld>
             <a:endParaRPr lang="en-US" dirty="0"/>
           </a:p>
@@ -5248,7 +5260,7 @@
           <a:p>
             <a:fld id="{B765778D-E9C8-418F-BCC2-C3C72FDE59B3}" type="datetimeFigureOut">
               <a:rPr lang="en-US" smtClean="0"/>
-              <a:t>8/7/2026</a:t>
+              <a:t>8/10/2026</a:t>
             </a:fld>
             <a:endParaRPr lang="en-US" dirty="0"/>
           </a:p>
@@ -5361,7 +5373,7 @@
           <a:p>
             <a:fld id="{B765778D-E9C8-418F-BCC2-C3C72FDE59B3}" type="datetimeFigureOut">
               <a:rPr lang="en-US" smtClean="0"/>
-              <a:t>8/7/2026</a:t>
+              <a:t>8/10/2026</a:t>
             </a:fld>
             <a:endParaRPr lang="en-US" dirty="0"/>
           </a:p>
@@ -5672,7 +5684,7 @@
           <a:p>
             <a:fld id="{B765778D-E9C8-418F-BCC2-C3C72FDE59B3}" type="datetimeFigureOut">
               <a:rPr lang="en-US" smtClean="0"/>
-              <a:t>8/7/2026</a:t>
+              <a:t>8/10/2026</a:t>
             </a:fld>
             <a:endParaRPr lang="en-US" dirty="0"/>
           </a:p>
@@ -5960,7 +5972,7 @@
           <a:p>
             <a:fld id="{B765778D-E9C8-418F-BCC2-C3C72FDE59B3}" type="datetimeFigureOut">
               <a:rPr lang="en-US" smtClean="0"/>
-              <a:t>8/7/2026</a:t>
+              <a:t>8/10/2026</a:t>
             </a:fld>
             <a:endParaRPr lang="en-US" dirty="0"/>
           </a:p>
@@ -6201,7 +6213,7 @@
           <a:p>
             <a:fld id="{B765778D-E9C8-418F-BCC2-C3C72FDE59B3}" type="datetimeFigureOut">
               <a:rPr lang="en-US" smtClean="0"/>
-              <a:t>8/7/2026</a:t>
+              <a:t>8/10/2026</a:t>
             </a:fld>
             <a:endParaRPr lang="en-US" dirty="0"/>
           </a:p>
@@ -6833,6 +6845,17 @@
             </a:r>
           </a:p>
           <a:p>
+            <a:r>
+              <a:rPr lang="en-US" dirty="0">
+                <a:solidFill>
+                  <a:srgbClr val="FFFF00"/>
+                </a:solidFill>
+                <a:latin typeface="Bahnschrift" panose="020B0502040204020203" pitchFamily="34" charset="0"/>
+              </a:rPr>
+              <a:t>Commands V3 is introducing a state machine class, so I would recommend looking at this as well.</a:t>
+            </a:r>
+          </a:p>
+          <a:p>
             <a:endParaRPr lang="en-US" dirty="0">
               <a:solidFill>
                 <a:srgbClr val="FFFF00"/>
@@ -6846,6 +6869,85 @@
     <p:extLst>
       <p:ext uri="{BB962C8B-B14F-4D97-AF65-F5344CB8AC3E}">
         <p14:creationId xmlns:p14="http://schemas.microsoft.com/office/powerpoint/2010/main" val="365852610"/>
+      </p:ext>
+    </p:extLst>
+  </p:cSld>
+  <p:clrMapOvr>
+    <a:masterClrMapping/>
+  </p:clrMapOvr>
+</p:sld>
+</file>
+
+<file path=ppt/slides/slide11.xml><?xml version="1.0" encoding="utf-8"?>
+<p:sld xmlns:a="http://schemas.openxmlformats.org/drawingml/2006/main" xmlns:r="http://schemas.openxmlformats.org/officeDocument/2006/relationships" xmlns:p="http://schemas.openxmlformats.org/presentationml/2006/main">
+  <p:cSld>
+    <p:bg>
+      <p:bgPr>
+        <a:solidFill>
+          <a:schemeClr val="accent3"/>
+        </a:solidFill>
+        <a:effectLst/>
+      </p:bgPr>
+    </p:bg>
+    <p:spTree>
+      <p:nvGrpSpPr>
+        <p:cNvPr id="1" name=""/>
+        <p:cNvGrpSpPr/>
+        <p:nvPr/>
+      </p:nvGrpSpPr>
+      <p:grpSpPr>
+        <a:xfrm>
+          <a:off x="0" y="0"/>
+          <a:ext cx="0" cy="0"/>
+          <a:chOff x="0" y="0"/>
+          <a:chExt cx="0" cy="0"/>
+        </a:xfrm>
+      </p:grpSpPr>
+      <p:sp>
+        <p:nvSpPr>
+          <p:cNvPr id="5" name="TextBox 4">
+            <a:extLst>
+              <a:ext uri="{FF2B5EF4-FFF2-40B4-BE49-F238E27FC236}">
+                <a16:creationId xmlns:a16="http://schemas.microsoft.com/office/drawing/2014/main" id="{ECD2714D-B8EC-9F95-4451-9A2394A4BA91}"/>
+              </a:ext>
+            </a:extLst>
+          </p:cNvPr>
+          <p:cNvSpPr txBox="1"/>
+          <p:nvPr/>
+        </p:nvSpPr>
+        <p:spPr>
+          <a:xfrm>
+            <a:off x="0" y="2828836"/>
+            <a:ext cx="12192000" cy="1200329"/>
+          </a:xfrm>
+          <a:prstGeom prst="rect">
+            <a:avLst/>
+          </a:prstGeom>
+          <a:noFill/>
+        </p:spPr>
+        <p:txBody>
+          <a:bodyPr wrap="square" rtlCol="0" anchor="ctr">
+            <a:spAutoFit/>
+          </a:bodyPr>
+          <a:lstStyle/>
+          <a:p>
+            <a:pPr algn="ctr"/>
+            <a:r>
+              <a:rPr lang="en-US" sz="7200" dirty="0">
+                <a:solidFill>
+                  <a:srgbClr val="FFFF00"/>
+                </a:solidFill>
+                <a:latin typeface="Black Ops One" pitchFamily="2" charset="0"/>
+              </a:rPr>
+              <a:t>Thank you for listening!</a:t>
+            </a:r>
+          </a:p>
+        </p:txBody>
+      </p:sp>
+    </p:spTree>
+    <p:extLst>
+      <p:ext uri="{BB962C8B-B14F-4D97-AF65-F5344CB8AC3E}">
+        <p14:creationId xmlns:p14="http://schemas.microsoft.com/office/powerpoint/2010/main" val="9223240"/>
       </p:ext>
     </p:extLst>
   </p:cSld>
@@ -7214,9 +7316,27 @@
             <a:off x="802434" y="217405"/>
             <a:ext cx="10587132" cy="6423190"/>
           </a:xfrm>
-          <a:prstGeom prst="rect">
-            <a:avLst/>
+          <a:prstGeom prst="roundRect">
+            <a:avLst>
+              <a:gd name="adj" fmla="val 11111"/>
+            </a:avLst>
           </a:prstGeom>
+          <a:ln w="190500" cap="rnd">
+            <a:noFill/>
+            <a:prstDash val="solid"/>
+          </a:ln>
+          <a:effectLst/>
+          <a:scene3d>
+            <a:camera prst="orthographicFront"/>
+            <a:lightRig rig="threePt" dir="t">
+              <a:rot lat="0" lon="0" rev="19200000"/>
+            </a:lightRig>
+          </a:scene3d>
+          <a:sp3d extrusionH="25400">
+            <a:extrusionClr>
+              <a:srgbClr val="FFFFFF"/>
+            </a:extrusionClr>
+          </a:sp3d>
         </p:spPr>
       </p:pic>
       <p:sp>
@@ -7675,7 +7795,25 @@
                 </a:solidFill>
                 <a:latin typeface="Bahnschrift" panose="020B0502040204020203" pitchFamily="34" charset="0"/>
               </a:rPr>
-              <a:t>A big point that I mentioned a few minutes ago (hopefully) is that everything is being run on the periodic loop.</a:t>
+              <a:t>A big point that I mentioned a </a:t>
+            </a:r>
+            <a:r>
+              <a:rPr lang="en-US">
+                <a:solidFill>
+                  <a:srgbClr val="FFFF00"/>
+                </a:solidFill>
+                <a:latin typeface="Bahnschrift" panose="020B0502040204020203" pitchFamily="34" charset="0"/>
+              </a:rPr>
+              <a:t>few moment ago (</a:t>
+            </a:r>
+            <a:r>
+              <a:rPr lang="en-US" dirty="0">
+                <a:solidFill>
+                  <a:srgbClr val="FFFF00"/>
+                </a:solidFill>
+                <a:latin typeface="Bahnschrift" panose="020B0502040204020203" pitchFamily="34" charset="0"/>
+              </a:rPr>
+              <a:t>hopefully) is that everything is being run on the periodic loop.</a:t>
             </a:r>
           </a:p>
           <a:p>

</xml_diff>

<commit_message>
Quick grammar fix for StateBased PPTX
</commit_message>
<xml_diff>
--- a/Presentations/StateBasedProgramming-Friday7PM.pptx
+++ b/Presentations/StateBasedProgramming-Friday7PM.pptx
@@ -3563,7 +3563,7 @@
           <a:p>
             <a:fld id="{B765778D-E9C8-418F-BCC2-C3C72FDE59B3}" type="datetimeFigureOut">
               <a:rPr lang="en-US" smtClean="0"/>
-              <a:t>8/10/2026</a:t>
+              <a:t>8/14/2026</a:t>
             </a:fld>
             <a:endParaRPr lang="en-US" dirty="0"/>
           </a:p>
@@ -3761,7 +3761,7 @@
           <a:p>
             <a:fld id="{B765778D-E9C8-418F-BCC2-C3C72FDE59B3}" type="datetimeFigureOut">
               <a:rPr lang="en-US" smtClean="0"/>
-              <a:t>8/10/2026</a:t>
+              <a:t>8/14/2026</a:t>
             </a:fld>
             <a:endParaRPr lang="en-US" dirty="0"/>
           </a:p>
@@ -3969,7 +3969,7 @@
           <a:p>
             <a:fld id="{B765778D-E9C8-418F-BCC2-C3C72FDE59B3}" type="datetimeFigureOut">
               <a:rPr lang="en-US" smtClean="0"/>
-              <a:t>8/10/2026</a:t>
+              <a:t>8/14/2026</a:t>
             </a:fld>
             <a:endParaRPr lang="en-US" dirty="0"/>
           </a:p>
@@ -4167,7 +4167,7 @@
           <a:p>
             <a:fld id="{B765778D-E9C8-418F-BCC2-C3C72FDE59B3}" type="datetimeFigureOut">
               <a:rPr lang="en-US" smtClean="0"/>
-              <a:t>8/10/2026</a:t>
+              <a:t>8/14/2026</a:t>
             </a:fld>
             <a:endParaRPr lang="en-US" dirty="0"/>
           </a:p>
@@ -4442,7 +4442,7 @@
           <a:p>
             <a:fld id="{B765778D-E9C8-418F-BCC2-C3C72FDE59B3}" type="datetimeFigureOut">
               <a:rPr lang="en-US" smtClean="0"/>
-              <a:t>8/10/2026</a:t>
+              <a:t>8/14/2026</a:t>
             </a:fld>
             <a:endParaRPr lang="en-US" dirty="0"/>
           </a:p>
@@ -4707,7 +4707,7 @@
           <a:p>
             <a:fld id="{B765778D-E9C8-418F-BCC2-C3C72FDE59B3}" type="datetimeFigureOut">
               <a:rPr lang="en-US" smtClean="0"/>
-              <a:t>8/10/2026</a:t>
+              <a:t>8/14/2026</a:t>
             </a:fld>
             <a:endParaRPr lang="en-US" dirty="0"/>
           </a:p>
@@ -5119,7 +5119,7 @@
           <a:p>
             <a:fld id="{B765778D-E9C8-418F-BCC2-C3C72FDE59B3}" type="datetimeFigureOut">
               <a:rPr lang="en-US" smtClean="0"/>
-              <a:t>8/10/2026</a:t>
+              <a:t>8/14/2026</a:t>
             </a:fld>
             <a:endParaRPr lang="en-US" dirty="0"/>
           </a:p>
@@ -5260,7 +5260,7 @@
           <a:p>
             <a:fld id="{B765778D-E9C8-418F-BCC2-C3C72FDE59B3}" type="datetimeFigureOut">
               <a:rPr lang="en-US" smtClean="0"/>
-              <a:t>8/10/2026</a:t>
+              <a:t>8/14/2026</a:t>
             </a:fld>
             <a:endParaRPr lang="en-US" dirty="0"/>
           </a:p>
@@ -5373,7 +5373,7 @@
           <a:p>
             <a:fld id="{B765778D-E9C8-418F-BCC2-C3C72FDE59B3}" type="datetimeFigureOut">
               <a:rPr lang="en-US" smtClean="0"/>
-              <a:t>8/10/2026</a:t>
+              <a:t>8/14/2026</a:t>
             </a:fld>
             <a:endParaRPr lang="en-US" dirty="0"/>
           </a:p>
@@ -5684,7 +5684,7 @@
           <a:p>
             <a:fld id="{B765778D-E9C8-418F-BCC2-C3C72FDE59B3}" type="datetimeFigureOut">
               <a:rPr lang="en-US" smtClean="0"/>
-              <a:t>8/10/2026</a:t>
+              <a:t>8/14/2026</a:t>
             </a:fld>
             <a:endParaRPr lang="en-US" dirty="0"/>
           </a:p>
@@ -5972,7 +5972,7 @@
           <a:p>
             <a:fld id="{B765778D-E9C8-418F-BCC2-C3C72FDE59B3}" type="datetimeFigureOut">
               <a:rPr lang="en-US" smtClean="0"/>
-              <a:t>8/10/2026</a:t>
+              <a:t>8/14/2026</a:t>
             </a:fld>
             <a:endParaRPr lang="en-US" dirty="0"/>
           </a:p>
@@ -6213,7 +6213,7 @@
           <a:p>
             <a:fld id="{B765778D-E9C8-418F-BCC2-C3C72FDE59B3}" type="datetimeFigureOut">
               <a:rPr lang="en-US" smtClean="0"/>
-              <a:t>8/10/2026</a:t>
+              <a:t>8/14/2026</a:t>
             </a:fld>
             <a:endParaRPr lang="en-US" dirty="0"/>
           </a:p>
@@ -7795,7 +7795,7 @@
                 </a:solidFill>
                 <a:latin typeface="Bahnschrift" panose="020B0502040204020203" pitchFamily="34" charset="0"/>
               </a:rPr>
-              <a:t>A big point that I mentioned a </a:t>
+              <a:t>A big point that I mentioned </a:t>
             </a:r>
             <a:r>
               <a:rPr lang="en-US">
@@ -7804,7 +7804,7 @@
                 </a:solidFill>
                 <a:latin typeface="Bahnschrift" panose="020B0502040204020203" pitchFamily="34" charset="0"/>
               </a:rPr>
-              <a:t>few moment ago (</a:t>
+              <a:t>a moment </a:t>
             </a:r>
             <a:r>
               <a:rPr lang="en-US" dirty="0">
@@ -7813,7 +7813,7 @@
                 </a:solidFill>
                 <a:latin typeface="Bahnschrift" panose="020B0502040204020203" pitchFamily="34" charset="0"/>
               </a:rPr>
-              <a:t>hopefully) is that everything is being run on the periodic loop.</a:t>
+              <a:t>ago (hopefully) is that everything is being run on the periodic loop.</a:t>
             </a:r>
           </a:p>
           <a:p>

</xml_diff>